<commit_message>
chore(ml-03): park run 299640 — 051 certified, paren sweep 41/41 clean, 048 att9 measurement decode complete (CONTINUATION_PROMPT.md); builds/final-deck/DB/qa evidence banked
</commit_message>
<xml_diff>
--- a/videos/machine-learning/03_ridger_regression_gradient_descent/recreated_pptx/slide_014_recreated.pptx
+++ b/videos/machine-learning/03_ridger_regression_gradient_descent/recreated_pptx/slide_014_recreated.pptx
@@ -884,7 +884,7 @@
         <p:spPr>
           <a:xfrm>
             <a:off x="685800" y="571500"/>
-            <a:ext cx="10782300" cy="6286500"/>
+            <a:ext cx="10795000" cy="6286500"/>
           </a:xfrm>
           <a:prstGeom prst="rect">
             <a:avLst/>
@@ -903,16 +903,19 @@
         </p:nvSpPr>
         <p:spPr>
           <a:xfrm>
-            <a:off x="742950" y="571500"/>
-            <a:ext cx="12700" cy="6286500"/>
-          </a:xfrm>
-          <a:prstGeom prst="rect">
-            <a:avLst/>
-          </a:prstGeom>
-          <a:solidFill>
-            <a:srgbClr val="C00000"/>
-          </a:solidFill>
-          <a:ln/>
+            <a:off x="742950" y="584200"/>
+            <a:ext cx="0" cy="6261100"/>
+          </a:xfrm>
+          <a:prstGeom prst="line">
+            <a:avLst/>
+          </a:prstGeom>
+          <a:noFill/>
+          <a:ln w="12700">
+            <a:solidFill>
+              <a:srgbClr val="C00000"/>
+            </a:solidFill>
+            <a:prstDash val="solid"/>
+          </a:ln>
         </p:spPr>
       </p:sp>
       <p:sp>
@@ -923,16 +926,19 @@
         </p:nvSpPr>
         <p:spPr>
           <a:xfrm>
-            <a:off x="11442700" y="571500"/>
-            <a:ext cx="12700" cy="6286500"/>
-          </a:xfrm>
-          <a:prstGeom prst="rect">
-            <a:avLst/>
-          </a:prstGeom>
-          <a:solidFill>
-            <a:srgbClr val="C00000"/>
-          </a:solidFill>
-          <a:ln/>
+            <a:off x="11442700" y="584200"/>
+            <a:ext cx="0" cy="6261100"/>
+          </a:xfrm>
+          <a:prstGeom prst="line">
+            <a:avLst/>
+          </a:prstGeom>
+          <a:noFill/>
+          <a:ln w="12700">
+            <a:solidFill>
+              <a:srgbClr val="C00000"/>
+            </a:solidFill>
+            <a:prstDash val="solid"/>
+          </a:ln>
         </p:spPr>
       </p:sp>
       <p:sp>
@@ -943,16 +949,19 @@
         </p:nvSpPr>
         <p:spPr>
           <a:xfrm>
-            <a:off x="685800" y="6838950"/>
-            <a:ext cx="10782300" cy="12700"/>
-          </a:xfrm>
-          <a:prstGeom prst="rect">
-            <a:avLst/>
-          </a:prstGeom>
-          <a:solidFill>
-            <a:srgbClr val="C00000"/>
-          </a:solidFill>
-          <a:ln/>
+            <a:off x="736600" y="6838950"/>
+            <a:ext cx="10718800" cy="0"/>
+          </a:xfrm>
+          <a:prstGeom prst="line">
+            <a:avLst/>
+          </a:prstGeom>
+          <a:noFill/>
+          <a:ln w="12700">
+            <a:solidFill>
+              <a:srgbClr val="C00000"/>
+            </a:solidFill>
+            <a:prstDash val="solid"/>
+          </a:ln>
         </p:spPr>
       </p:sp>
       <p:sp>
@@ -972,7 +981,7 @@
           <a:solidFill>
             <a:srgbClr val="FDFD96"/>
           </a:solidFill>
-          <a:ln w="12700">
+          <a:ln w="25400">
             <a:solidFill>
               <a:srgbClr val="6A5ACD"/>
             </a:solidFill>

</xml_diff>